<commit_message>
feat(auth): barangay-issued resident accounts with optional email notifications
- Replace public self-signup and email OTP with a staff-only create-account action. Barangay office issues logins (Add Resident / Create Login), sets the initial password; accounts are active immediately with no verification or approval queue.
- Remove signup and accounts-approval pages and their proxy/public path entries.
- Add queued SMTP notifications (nodemailer) with an offline mode when SMTP_PASS is unset; drained by instrumentation every 30s.
- Apply migration 20260911 (email_queue, notifications, users fields) and document the new account model in README.
- Ship the updated 10-slide client presentation deck.
</commit_message>
<xml_diff>
--- a/BarangayConnect_Presentation.pptx
+++ b/BarangayConnect_Presentation.pptx
@@ -10,8 +10,10 @@
     <p:sldId id="258" r:id="rId9"/>
     <p:sldId id="259" r:id="rId10"/>
     <p:sldId id="260" r:id="rId11"/>
+    <p:sldId id="264" r:id="rId15"/>
     <p:sldId id="261" r:id="rId12"/>
     <p:sldId id="262" r:id="rId13"/>
+    <p:sldId id="265" r:id="rId16"/>
     <p:sldId id="263" r:id="rId14"/>
   </p:sldIdLst>
   <p:sldSz cx="12191695" cy="6858000" type="screen4x3"/>
@@ -3512,6 +3514,1557 @@
 </p:sld>
 </file>
 
+<file path=ppt/slides/slide10.xml><?xml version="1.0" encoding="utf-8"?>
+<p:sld xmlns:a="http://schemas.openxmlformats.org/drawingml/2006/main" xmlns:p="http://schemas.openxmlformats.org/presentationml/2006/main" xmlns:r="http://schemas.openxmlformats.org/officeDocument/2006/relationships">
+  <p:cSld>
+    <p:spTree>
+      <p:nvGrpSpPr>
+        <p:cNvPr id="1" name=""/>
+        <p:cNvGrpSpPr/>
+        <p:nvPr/>
+      </p:nvGrpSpPr>
+      <p:grpSpPr/>
+      <p:sp>
+        <p:nvSpPr>
+          <p:cNvPr id="2" name="Rectangle 1"/>
+          <p:cNvSpPr/>
+          <p:nvPr/>
+        </p:nvSpPr>
+        <p:spPr>
+          <a:xfrm>
+            <a:off x="0" y="0"/>
+            <a:ext cx="12191695" cy="1234440"/>
+          </a:xfrm>
+          <a:prstGeom prst="rect">
+            <a:avLst/>
+          </a:prstGeom>
+          <a:solidFill>
+            <a:srgbClr val="0F2A4C"/>
+          </a:solidFill>
+          <a:ln>
+            <a:noFill/>
+          </a:ln>
+          <a:effectLst/>
+        </p:spPr>
+        <p:style>
+          <a:lnRef idx="1">
+            <a:schemeClr val="accent1"/>
+          </a:lnRef>
+          <a:fillRef idx="3">
+            <a:schemeClr val="accent1"/>
+          </a:fillRef>
+          <a:effectRef idx="2">
+            <a:schemeClr val="accent1"/>
+          </a:effectRef>
+          <a:fontRef idx="minor">
+            <a:schemeClr val="lt1"/>
+          </a:fontRef>
+        </p:style>
+        <p:txBody>
+          <a:bodyPr rtlCol="0" anchor="ctr"/>
+          <a:lstStyle/>
+          <a:p>
+            <a:pPr algn="ctr"/>
+          </a:p>
+        </p:txBody>
+      </p:sp>
+      <p:sp>
+        <p:nvSpPr>
+          <p:cNvPr id="3" name="Rectangle 2"/>
+          <p:cNvSpPr/>
+          <p:nvPr/>
+        </p:nvSpPr>
+        <p:spPr>
+          <a:xfrm>
+            <a:off x="0" y="1234440"/>
+            <a:ext cx="12191695" cy="50800"/>
+          </a:xfrm>
+          <a:prstGeom prst="rect">
+            <a:avLst/>
+          </a:prstGeom>
+          <a:solidFill>
+            <a:srgbClr val="F2B418"/>
+          </a:solidFill>
+          <a:ln>
+            <a:noFill/>
+          </a:ln>
+          <a:effectLst/>
+        </p:spPr>
+        <p:style>
+          <a:lnRef idx="1">
+            <a:schemeClr val="accent1"/>
+          </a:lnRef>
+          <a:fillRef idx="3">
+            <a:schemeClr val="accent1"/>
+          </a:fillRef>
+          <a:effectRef idx="2">
+            <a:schemeClr val="accent1"/>
+          </a:effectRef>
+          <a:fontRef idx="minor">
+            <a:schemeClr val="lt1"/>
+          </a:fontRef>
+        </p:style>
+        <p:txBody>
+          <a:bodyPr rtlCol="0" anchor="ctr"/>
+          <a:lstStyle/>
+          <a:p>
+            <a:pPr algn="ctr"/>
+          </a:p>
+        </p:txBody>
+      </p:sp>
+      <p:sp>
+        <p:nvSpPr>
+          <p:cNvPr id="4" name="TextBox 3"/>
+          <p:cNvSpPr txBox="1"/>
+          <p:nvPr/>
+        </p:nvSpPr>
+        <p:spPr>
+          <a:xfrm>
+            <a:off x="640080" y="0"/>
+            <a:ext cx="8686800" cy="1234440"/>
+          </a:xfrm>
+          <a:prstGeom prst="rect">
+            <a:avLst/>
+          </a:prstGeom>
+          <a:noFill/>
+        </p:spPr>
+        <p:txBody>
+          <a:bodyPr wrap="square" anchor="ctr" lIns="0" rIns="0" tIns="0" bIns="0">
+            <a:spAutoFit/>
+          </a:bodyPr>
+          <a:lstStyle/>
+          <a:p>
+            <a:pPr algn="l"/>
+            <a:r>
+              <a:rPr sz="3000" b="1">
+                <a:solidFill>
+                  <a:srgbClr val="FFFFFF"/>
+                </a:solidFill>
+                <a:latin typeface="Calibri"/>
+              </a:rPr>
+              <a:t>On-Premise &amp; Operations</a:t>
+            </a:r>
+          </a:p>
+        </p:txBody>
+      </p:sp>
+      <p:sp>
+        <p:nvSpPr>
+          <p:cNvPr id="5" name="TextBox 4"/>
+          <p:cNvSpPr txBox="1"/>
+          <p:nvPr/>
+        </p:nvSpPr>
+        <p:spPr>
+          <a:xfrm>
+            <a:off x="8778240" y="0"/>
+            <a:ext cx="2834640" cy="1234440"/>
+          </a:xfrm>
+          <a:prstGeom prst="rect">
+            <a:avLst/>
+          </a:prstGeom>
+          <a:noFill/>
+        </p:spPr>
+        <p:txBody>
+          <a:bodyPr wrap="square" anchor="ctr" lIns="0" rIns="0" tIns="0" bIns="0">
+            <a:spAutoFit/>
+          </a:bodyPr>
+          <a:lstStyle/>
+          <a:p>
+            <a:pPr algn="r"/>
+            <a:r>
+              <a:rPr sz="1200" b="0">
+                <a:solidFill>
+                  <a:srgbClr val="C9D6E8"/>
+                </a:solidFill>
+                <a:latin typeface="Calibri"/>
+              </a:rPr>
+              <a:t>Self-hosted, always on, always backed up</a:t>
+            </a:r>
+          </a:p>
+        </p:txBody>
+      </p:sp>
+      <p:sp>
+        <p:nvSpPr>
+          <p:cNvPr id="6" name="Rectangle 5"/>
+          <p:cNvSpPr/>
+          <p:nvPr/>
+        </p:nvSpPr>
+        <p:spPr>
+          <a:xfrm>
+            <a:off x="11231575" y="0"/>
+            <a:ext cx="960120" cy="384048"/>
+          </a:xfrm>
+          <a:prstGeom prst="rect">
+            <a:avLst/>
+          </a:prstGeom>
+          <a:solidFill>
+            <a:srgbClr val="F2B418"/>
+          </a:solidFill>
+          <a:ln>
+            <a:noFill/>
+          </a:ln>
+          <a:effectLst/>
+        </p:spPr>
+        <p:style>
+          <a:lnRef idx="1">
+            <a:schemeClr val="accent1"/>
+          </a:lnRef>
+          <a:fillRef idx="3">
+            <a:schemeClr val="accent1"/>
+          </a:fillRef>
+          <a:effectRef idx="2">
+            <a:schemeClr val="accent1"/>
+          </a:effectRef>
+          <a:fontRef idx="minor">
+            <a:schemeClr val="lt1"/>
+          </a:fontRef>
+        </p:style>
+        <p:txBody>
+          <a:bodyPr rtlCol="0" anchor="ctr"/>
+          <a:lstStyle/>
+          <a:p>
+            <a:pPr algn="ctr"/>
+          </a:p>
+        </p:txBody>
+      </p:sp>
+      <p:sp>
+        <p:nvSpPr>
+          <p:cNvPr id="7" name="TextBox 6"/>
+          <p:cNvSpPr txBox="1"/>
+          <p:nvPr/>
+        </p:nvSpPr>
+        <p:spPr>
+          <a:xfrm>
+            <a:off x="11231575" y="0"/>
+            <a:ext cx="960120" cy="384048"/>
+          </a:xfrm>
+          <a:prstGeom prst="rect">
+            <a:avLst/>
+          </a:prstGeom>
+          <a:noFill/>
+        </p:spPr>
+        <p:txBody>
+          <a:bodyPr wrap="square" anchor="ctr" lIns="0" rIns="0" tIns="0" bIns="0">
+            <a:spAutoFit/>
+          </a:bodyPr>
+          <a:lstStyle/>
+          <a:p>
+            <a:pPr algn="ctr"/>
+            <a:r>
+              <a:rPr sz="1400" b="1">
+                <a:solidFill>
+                  <a:srgbClr val="0F2A4C"/>
+                </a:solidFill>
+                <a:latin typeface="Calibri"/>
+              </a:rPr>
+              <a:t>BC</a:t>
+            </a:r>
+          </a:p>
+        </p:txBody>
+      </p:sp>
+      <p:sp>
+        <p:nvSpPr>
+          <p:cNvPr id="8" name="Rounded Rectangle 7"/>
+          <p:cNvSpPr/>
+          <p:nvPr/>
+        </p:nvSpPr>
+        <p:spPr>
+          <a:xfrm>
+            <a:off x="594360" y="1554480"/>
+            <a:ext cx="5303520" cy="914400"/>
+          </a:xfrm>
+          <a:prstGeom prst="roundRect">
+            <a:avLst/>
+          </a:prstGeom>
+          <a:solidFill>
+            <a:srgbClr val="FFFFFF"/>
+          </a:solidFill>
+          <a:ln>
+            <a:noFill/>
+          </a:ln>
+          <a:effectLst/>
+        </p:spPr>
+        <p:style>
+          <a:lnRef idx="1">
+            <a:schemeClr val="accent1"/>
+          </a:lnRef>
+          <a:fillRef idx="3">
+            <a:schemeClr val="accent1"/>
+          </a:fillRef>
+          <a:effectRef idx="2">
+            <a:schemeClr val="accent1"/>
+          </a:effectRef>
+          <a:fontRef idx="minor">
+            <a:schemeClr val="lt1"/>
+          </a:fontRef>
+        </p:style>
+        <p:txBody>
+          <a:bodyPr rtlCol="0" anchor="ctr"/>
+          <a:lstStyle/>
+          <a:p>
+            <a:pPr algn="ctr"/>
+          </a:p>
+        </p:txBody>
+      </p:sp>
+      <p:sp>
+        <p:nvSpPr>
+          <p:cNvPr id="9" name="Rectangle 8"/>
+          <p:cNvSpPr/>
+          <p:nvPr/>
+        </p:nvSpPr>
+        <p:spPr>
+          <a:xfrm>
+            <a:off x="594360" y="1554480"/>
+            <a:ext cx="82296" cy="914400"/>
+          </a:xfrm>
+          <a:prstGeom prst="rect">
+            <a:avLst/>
+          </a:prstGeom>
+          <a:solidFill>
+            <a:srgbClr val="F2B418"/>
+          </a:solidFill>
+          <a:ln>
+            <a:noFill/>
+          </a:ln>
+          <a:effectLst/>
+        </p:spPr>
+        <p:style>
+          <a:lnRef idx="1">
+            <a:schemeClr val="accent1"/>
+          </a:lnRef>
+          <a:fillRef idx="3">
+            <a:schemeClr val="accent1"/>
+          </a:fillRef>
+          <a:effectRef idx="2">
+            <a:schemeClr val="accent1"/>
+          </a:effectRef>
+          <a:fontRef idx="minor">
+            <a:schemeClr val="lt1"/>
+          </a:fontRef>
+        </p:style>
+        <p:txBody>
+          <a:bodyPr rtlCol="0" anchor="ctr"/>
+          <a:lstStyle/>
+          <a:p>
+            <a:pPr algn="ctr"/>
+          </a:p>
+        </p:txBody>
+      </p:sp>
+      <p:sp>
+        <p:nvSpPr>
+          <p:cNvPr id="10" name="TextBox 9"/>
+          <p:cNvSpPr txBox="1"/>
+          <p:nvPr/>
+        </p:nvSpPr>
+        <p:spPr>
+          <a:xfrm>
+            <a:off x="868680" y="1664208"/>
+            <a:ext cx="4846320" cy="411480"/>
+          </a:xfrm>
+          <a:prstGeom prst="rect">
+            <a:avLst/>
+          </a:prstGeom>
+          <a:noFill/>
+        </p:spPr>
+        <p:txBody>
+          <a:bodyPr wrap="square" anchor="ctr" lIns="0" rIns="0" tIns="0" bIns="0">
+            <a:spAutoFit/>
+          </a:bodyPr>
+          <a:lstStyle/>
+          <a:p>
+            <a:pPr algn="l"/>
+            <a:r>
+              <a:rPr sz="1500" b="1">
+                <a:solidFill>
+                  <a:srgbClr val="0F2A4C"/>
+                </a:solidFill>
+                <a:latin typeface="Calibri"/>
+              </a:rPr>
+              <a:t>Fully Self-Hosted</a:t>
+            </a:r>
+          </a:p>
+        </p:txBody>
+      </p:sp>
+      <p:sp>
+        <p:nvSpPr>
+          <p:cNvPr id="11" name="TextBox 10"/>
+          <p:cNvSpPr txBox="1"/>
+          <p:nvPr/>
+        </p:nvSpPr>
+        <p:spPr>
+          <a:xfrm>
+            <a:off x="868680" y="2029968"/>
+            <a:ext cx="4846320" cy="365760"/>
+          </a:xfrm>
+          <a:prstGeom prst="rect">
+            <a:avLst/>
+          </a:prstGeom>
+          <a:noFill/>
+        </p:spPr>
+        <p:txBody>
+          <a:bodyPr wrap="square" anchor="t" lIns="0" rIns="0" tIns="0" bIns="0">
+            <a:spAutoFit/>
+          </a:bodyPr>
+          <a:lstStyle/>
+          <a:p>
+            <a:pPr algn="l">
+              <a:lnSpc>
+                <a:spcPct val="110000"/>
+              </a:lnSpc>
+            </a:pPr>
+            <a:r>
+              <a:rPr sz="1500" b="0">
+                <a:solidFill>
+                  <a:srgbClr val="243244"/>
+                </a:solidFill>
+                <a:latin typeface="Calibri"/>
+              </a:rPr>
+              <a:t>Runs on the barangay's own machine over the local network.</a:t>
+            </a:r>
+          </a:p>
+        </p:txBody>
+      </p:sp>
+      <p:sp>
+        <p:nvSpPr>
+          <p:cNvPr id="12" name="Rounded Rectangle 11"/>
+          <p:cNvSpPr/>
+          <p:nvPr/>
+        </p:nvSpPr>
+        <p:spPr>
+          <a:xfrm>
+            <a:off x="6309360" y="1554480"/>
+            <a:ext cx="5303520" cy="914400"/>
+          </a:xfrm>
+          <a:prstGeom prst="roundRect">
+            <a:avLst/>
+          </a:prstGeom>
+          <a:solidFill>
+            <a:srgbClr val="FFFFFF"/>
+          </a:solidFill>
+          <a:ln>
+            <a:noFill/>
+          </a:ln>
+          <a:effectLst/>
+        </p:spPr>
+        <p:style>
+          <a:lnRef idx="1">
+            <a:schemeClr val="accent1"/>
+          </a:lnRef>
+          <a:fillRef idx="3">
+            <a:schemeClr val="accent1"/>
+          </a:fillRef>
+          <a:effectRef idx="2">
+            <a:schemeClr val="accent1"/>
+          </a:effectRef>
+          <a:fontRef idx="minor">
+            <a:schemeClr val="lt1"/>
+          </a:fontRef>
+        </p:style>
+        <p:txBody>
+          <a:bodyPr rtlCol="0" anchor="ctr"/>
+          <a:lstStyle/>
+          <a:p>
+            <a:pPr algn="ctr"/>
+          </a:p>
+        </p:txBody>
+      </p:sp>
+      <p:sp>
+        <p:nvSpPr>
+          <p:cNvPr id="13" name="Rectangle 12"/>
+          <p:cNvSpPr/>
+          <p:nvPr/>
+        </p:nvSpPr>
+        <p:spPr>
+          <a:xfrm>
+            <a:off x="6309360" y="1554480"/>
+            <a:ext cx="82296" cy="914400"/>
+          </a:xfrm>
+          <a:prstGeom prst="rect">
+            <a:avLst/>
+          </a:prstGeom>
+          <a:solidFill>
+            <a:srgbClr val="F2B418"/>
+          </a:solidFill>
+          <a:ln>
+            <a:noFill/>
+          </a:ln>
+          <a:effectLst/>
+        </p:spPr>
+        <p:style>
+          <a:lnRef idx="1">
+            <a:schemeClr val="accent1"/>
+          </a:lnRef>
+          <a:fillRef idx="3">
+            <a:schemeClr val="accent1"/>
+          </a:fillRef>
+          <a:effectRef idx="2">
+            <a:schemeClr val="accent1"/>
+          </a:effectRef>
+          <a:fontRef idx="minor">
+            <a:schemeClr val="lt1"/>
+          </a:fontRef>
+        </p:style>
+        <p:txBody>
+          <a:bodyPr rtlCol="0" anchor="ctr"/>
+          <a:lstStyle/>
+          <a:p>
+            <a:pPr algn="ctr"/>
+          </a:p>
+        </p:txBody>
+      </p:sp>
+      <p:sp>
+        <p:nvSpPr>
+          <p:cNvPr id="14" name="TextBox 13"/>
+          <p:cNvSpPr txBox="1"/>
+          <p:nvPr/>
+        </p:nvSpPr>
+        <p:spPr>
+          <a:xfrm>
+            <a:off x="6583680" y="1664208"/>
+            <a:ext cx="4846320" cy="411480"/>
+          </a:xfrm>
+          <a:prstGeom prst="rect">
+            <a:avLst/>
+          </a:prstGeom>
+          <a:noFill/>
+        </p:spPr>
+        <p:txBody>
+          <a:bodyPr wrap="square" anchor="ctr" lIns="0" rIns="0" tIns="0" bIns="0">
+            <a:spAutoFit/>
+          </a:bodyPr>
+          <a:lstStyle/>
+          <a:p>
+            <a:pPr algn="l"/>
+            <a:r>
+              <a:rPr sz="1500" b="1">
+                <a:solidFill>
+                  <a:srgbClr val="0F2A4C"/>
+                </a:solidFill>
+                <a:latin typeface="Calibri"/>
+              </a:rPr>
+              <a:t>On-Premise PostgreSQL</a:t>
+            </a:r>
+          </a:p>
+        </p:txBody>
+      </p:sp>
+      <p:sp>
+        <p:nvSpPr>
+          <p:cNvPr id="15" name="TextBox 14"/>
+          <p:cNvSpPr txBox="1"/>
+          <p:nvPr/>
+        </p:nvSpPr>
+        <p:spPr>
+          <a:xfrm>
+            <a:off x="6583680" y="2029968"/>
+            <a:ext cx="4846320" cy="365760"/>
+          </a:xfrm>
+          <a:prstGeom prst="rect">
+            <a:avLst/>
+          </a:prstGeom>
+          <a:noFill/>
+        </p:spPr>
+        <p:txBody>
+          <a:bodyPr wrap="square" anchor="t" lIns="0" rIns="0" tIns="0" bIns="0">
+            <a:spAutoFit/>
+          </a:bodyPr>
+          <a:lstStyle/>
+          <a:p>
+            <a:pPr algn="l">
+              <a:lnSpc>
+                <a:spcPct val="110000"/>
+              </a:lnSpc>
+            </a:pPr>
+            <a:r>
+              <a:rPr sz="1500" b="0">
+                <a:solidFill>
+                  <a:srgbClr val="243244"/>
+                </a:solidFill>
+                <a:latin typeface="Calibri"/>
+              </a:rPr>
+              <a:t>Data is stored locally - nothing leaves the barangay.</a:t>
+            </a:r>
+          </a:p>
+        </p:txBody>
+      </p:sp>
+      <p:sp>
+        <p:nvSpPr>
+          <p:cNvPr id="16" name="Rounded Rectangle 15"/>
+          <p:cNvSpPr/>
+          <p:nvPr/>
+        </p:nvSpPr>
+        <p:spPr>
+          <a:xfrm>
+            <a:off x="594360" y="3063240"/>
+            <a:ext cx="5303520" cy="914400"/>
+          </a:xfrm>
+          <a:prstGeom prst="roundRect">
+            <a:avLst/>
+          </a:prstGeom>
+          <a:solidFill>
+            <a:srgbClr val="FFFFFF"/>
+          </a:solidFill>
+          <a:ln>
+            <a:noFill/>
+          </a:ln>
+          <a:effectLst/>
+        </p:spPr>
+        <p:style>
+          <a:lnRef idx="1">
+            <a:schemeClr val="accent1"/>
+          </a:lnRef>
+          <a:fillRef idx="3">
+            <a:schemeClr val="accent1"/>
+          </a:fillRef>
+          <a:effectRef idx="2">
+            <a:schemeClr val="accent1"/>
+          </a:effectRef>
+          <a:fontRef idx="minor">
+            <a:schemeClr val="lt1"/>
+          </a:fontRef>
+        </p:style>
+        <p:txBody>
+          <a:bodyPr rtlCol="0" anchor="ctr"/>
+          <a:lstStyle/>
+          <a:p>
+            <a:pPr algn="ctr"/>
+          </a:p>
+        </p:txBody>
+      </p:sp>
+      <p:sp>
+        <p:nvSpPr>
+          <p:cNvPr id="17" name="Rectangle 16"/>
+          <p:cNvSpPr/>
+          <p:nvPr/>
+        </p:nvSpPr>
+        <p:spPr>
+          <a:xfrm>
+            <a:off x="594360" y="3063240"/>
+            <a:ext cx="82296" cy="914400"/>
+          </a:xfrm>
+          <a:prstGeom prst="rect">
+            <a:avLst/>
+          </a:prstGeom>
+          <a:solidFill>
+            <a:srgbClr val="F2B418"/>
+          </a:solidFill>
+          <a:ln>
+            <a:noFill/>
+          </a:ln>
+          <a:effectLst/>
+        </p:spPr>
+        <p:style>
+          <a:lnRef idx="1">
+            <a:schemeClr val="accent1"/>
+          </a:lnRef>
+          <a:fillRef idx="3">
+            <a:schemeClr val="accent1"/>
+          </a:fillRef>
+          <a:effectRef idx="2">
+            <a:schemeClr val="accent1"/>
+          </a:effectRef>
+          <a:fontRef idx="minor">
+            <a:schemeClr val="lt1"/>
+          </a:fontRef>
+        </p:style>
+        <p:txBody>
+          <a:bodyPr rtlCol="0" anchor="ctr"/>
+          <a:lstStyle/>
+          <a:p>
+            <a:pPr algn="ctr"/>
+          </a:p>
+        </p:txBody>
+      </p:sp>
+      <p:sp>
+        <p:nvSpPr>
+          <p:cNvPr id="18" name="TextBox 17"/>
+          <p:cNvSpPr txBox="1"/>
+          <p:nvPr/>
+        </p:nvSpPr>
+        <p:spPr>
+          <a:xfrm>
+            <a:off x="868680" y="3172968"/>
+            <a:ext cx="4846320" cy="411480"/>
+          </a:xfrm>
+          <a:prstGeom prst="rect">
+            <a:avLst/>
+          </a:prstGeom>
+          <a:noFill/>
+        </p:spPr>
+        <p:txBody>
+          <a:bodyPr wrap="square" anchor="ctr" lIns="0" rIns="0" tIns="0" bIns="0">
+            <a:spAutoFit/>
+          </a:bodyPr>
+          <a:lstStyle/>
+          <a:p>
+            <a:pPr algn="l"/>
+            <a:r>
+              <a:rPr sz="1500" b="1">
+                <a:solidFill>
+                  <a:srgbClr val="0F2A4C"/>
+                </a:solidFill>
+                <a:latin typeface="Calibri"/>
+              </a:rPr>
+              <a:t>Scheduled Auto-Start</a:t>
+            </a:r>
+          </a:p>
+        </p:txBody>
+      </p:sp>
+      <p:sp>
+        <p:nvSpPr>
+          <p:cNvPr id="19" name="TextBox 18"/>
+          <p:cNvSpPr txBox="1"/>
+          <p:nvPr/>
+        </p:nvSpPr>
+        <p:spPr>
+          <a:xfrm>
+            <a:off x="868680" y="3538728"/>
+            <a:ext cx="4846320" cy="365760"/>
+          </a:xfrm>
+          <a:prstGeom prst="rect">
+            <a:avLst/>
+          </a:prstGeom>
+          <a:noFill/>
+        </p:spPr>
+        <p:txBody>
+          <a:bodyPr wrap="square" anchor="t" lIns="0" rIns="0" tIns="0" bIns="0">
+            <a:spAutoFit/>
+          </a:bodyPr>
+          <a:lstStyle/>
+          <a:p>
+            <a:pPr algn="l">
+              <a:lnSpc>
+                <a:spcPct val="110000"/>
+              </a:lnSpc>
+            </a:pPr>
+            <a:r>
+              <a:rPr sz="1500" b="0">
+                <a:solidFill>
+                  <a:srgbClr val="243244"/>
+                </a:solidFill>
+                <a:latin typeface="Calibri"/>
+              </a:rPr>
+              <a:t>App and tunnel launch automatically at boot.</a:t>
+            </a:r>
+          </a:p>
+        </p:txBody>
+      </p:sp>
+      <p:sp>
+        <p:nvSpPr>
+          <p:cNvPr id="20" name="Rounded Rectangle 19"/>
+          <p:cNvSpPr/>
+          <p:nvPr/>
+        </p:nvSpPr>
+        <p:spPr>
+          <a:xfrm>
+            <a:off x="6309360" y="3063240"/>
+            <a:ext cx="5303520" cy="914400"/>
+          </a:xfrm>
+          <a:prstGeom prst="roundRect">
+            <a:avLst/>
+          </a:prstGeom>
+          <a:solidFill>
+            <a:srgbClr val="FFFFFF"/>
+          </a:solidFill>
+          <a:ln>
+            <a:noFill/>
+          </a:ln>
+          <a:effectLst/>
+        </p:spPr>
+        <p:style>
+          <a:lnRef idx="1">
+            <a:schemeClr val="accent1"/>
+          </a:lnRef>
+          <a:fillRef idx="3">
+            <a:schemeClr val="accent1"/>
+          </a:fillRef>
+          <a:effectRef idx="2">
+            <a:schemeClr val="accent1"/>
+          </a:effectRef>
+          <a:fontRef idx="minor">
+            <a:schemeClr val="lt1"/>
+          </a:fontRef>
+        </p:style>
+        <p:txBody>
+          <a:bodyPr rtlCol="0" anchor="ctr"/>
+          <a:lstStyle/>
+          <a:p>
+            <a:pPr algn="ctr"/>
+          </a:p>
+        </p:txBody>
+      </p:sp>
+      <p:sp>
+        <p:nvSpPr>
+          <p:cNvPr id="21" name="Rectangle 20"/>
+          <p:cNvSpPr/>
+          <p:nvPr/>
+        </p:nvSpPr>
+        <p:spPr>
+          <a:xfrm>
+            <a:off x="6309360" y="3063240"/>
+            <a:ext cx="82296" cy="914400"/>
+          </a:xfrm>
+          <a:prstGeom prst="rect">
+            <a:avLst/>
+          </a:prstGeom>
+          <a:solidFill>
+            <a:srgbClr val="F2B418"/>
+          </a:solidFill>
+          <a:ln>
+            <a:noFill/>
+          </a:ln>
+          <a:effectLst/>
+        </p:spPr>
+        <p:style>
+          <a:lnRef idx="1">
+            <a:schemeClr val="accent1"/>
+          </a:lnRef>
+          <a:fillRef idx="3">
+            <a:schemeClr val="accent1"/>
+          </a:fillRef>
+          <a:effectRef idx="2">
+            <a:schemeClr val="accent1"/>
+          </a:effectRef>
+          <a:fontRef idx="minor">
+            <a:schemeClr val="lt1"/>
+          </a:fontRef>
+        </p:style>
+        <p:txBody>
+          <a:bodyPr rtlCol="0" anchor="ctr"/>
+          <a:lstStyle/>
+          <a:p>
+            <a:pPr algn="ctr"/>
+          </a:p>
+        </p:txBody>
+      </p:sp>
+      <p:sp>
+        <p:nvSpPr>
+          <p:cNvPr id="22" name="TextBox 21"/>
+          <p:cNvSpPr txBox="1"/>
+          <p:nvPr/>
+        </p:nvSpPr>
+        <p:spPr>
+          <a:xfrm>
+            <a:off x="6583680" y="3172968"/>
+            <a:ext cx="4846320" cy="411480"/>
+          </a:xfrm>
+          <a:prstGeom prst="rect">
+            <a:avLst/>
+          </a:prstGeom>
+          <a:noFill/>
+        </p:spPr>
+        <p:txBody>
+          <a:bodyPr wrap="square" anchor="ctr" lIns="0" rIns="0" tIns="0" bIns="0">
+            <a:spAutoFit/>
+          </a:bodyPr>
+          <a:lstStyle/>
+          <a:p>
+            <a:pPr algn="l"/>
+            <a:r>
+              <a:rPr sz="1500" b="1">
+                <a:solidFill>
+                  <a:srgbClr val="0F2A4C"/>
+                </a:solidFill>
+                <a:latin typeface="Calibri"/>
+              </a:rPr>
+              <a:t>Health Monitoring</a:t>
+            </a:r>
+          </a:p>
+        </p:txBody>
+      </p:sp>
+      <p:sp>
+        <p:nvSpPr>
+          <p:cNvPr id="23" name="TextBox 22"/>
+          <p:cNvSpPr txBox="1"/>
+          <p:nvPr/>
+        </p:nvSpPr>
+        <p:spPr>
+          <a:xfrm>
+            <a:off x="6583680" y="3538728"/>
+            <a:ext cx="4846320" cy="365760"/>
+          </a:xfrm>
+          <a:prstGeom prst="rect">
+            <a:avLst/>
+          </a:prstGeom>
+          <a:noFill/>
+        </p:spPr>
+        <p:txBody>
+          <a:bodyPr wrap="square" anchor="t" lIns="0" rIns="0" tIns="0" bIns="0">
+            <a:spAutoFit/>
+          </a:bodyPr>
+          <a:lstStyle/>
+          <a:p>
+            <a:pPr algn="l">
+              <a:lnSpc>
+                <a:spcPct val="110000"/>
+              </a:lnSpc>
+            </a:pPr>
+            <a:r>
+              <a:rPr sz="1500" b="0">
+                <a:solidFill>
+                  <a:srgbClr val="243244"/>
+                </a:solidFill>
+                <a:latin typeface="Calibri"/>
+              </a:rPr>
+              <a:t>Watches uptime and restarts services on failure.</a:t>
+            </a:r>
+          </a:p>
+        </p:txBody>
+      </p:sp>
+      <p:sp>
+        <p:nvSpPr>
+          <p:cNvPr id="24" name="Rounded Rectangle 23"/>
+          <p:cNvSpPr/>
+          <p:nvPr/>
+        </p:nvSpPr>
+        <p:spPr>
+          <a:xfrm>
+            <a:off x="594360" y="4572000"/>
+            <a:ext cx="5303520" cy="914400"/>
+          </a:xfrm>
+          <a:prstGeom prst="roundRect">
+            <a:avLst/>
+          </a:prstGeom>
+          <a:solidFill>
+            <a:srgbClr val="FFFFFF"/>
+          </a:solidFill>
+          <a:ln>
+            <a:noFill/>
+          </a:ln>
+          <a:effectLst/>
+        </p:spPr>
+        <p:style>
+          <a:lnRef idx="1">
+            <a:schemeClr val="accent1"/>
+          </a:lnRef>
+          <a:fillRef idx="3">
+            <a:schemeClr val="accent1"/>
+          </a:fillRef>
+          <a:effectRef idx="2">
+            <a:schemeClr val="accent1"/>
+          </a:effectRef>
+          <a:fontRef idx="minor">
+            <a:schemeClr val="lt1"/>
+          </a:fontRef>
+        </p:style>
+        <p:txBody>
+          <a:bodyPr rtlCol="0" anchor="ctr"/>
+          <a:lstStyle/>
+          <a:p>
+            <a:pPr algn="ctr"/>
+          </a:p>
+        </p:txBody>
+      </p:sp>
+      <p:sp>
+        <p:nvSpPr>
+          <p:cNvPr id="25" name="Rectangle 24"/>
+          <p:cNvSpPr/>
+          <p:nvPr/>
+        </p:nvSpPr>
+        <p:spPr>
+          <a:xfrm>
+            <a:off x="594360" y="4572000"/>
+            <a:ext cx="82296" cy="914400"/>
+          </a:xfrm>
+          <a:prstGeom prst="rect">
+            <a:avLst/>
+          </a:prstGeom>
+          <a:solidFill>
+            <a:srgbClr val="F2B418"/>
+          </a:solidFill>
+          <a:ln>
+            <a:noFill/>
+          </a:ln>
+          <a:effectLst/>
+        </p:spPr>
+        <p:style>
+          <a:lnRef idx="1">
+            <a:schemeClr val="accent1"/>
+          </a:lnRef>
+          <a:fillRef idx="3">
+            <a:schemeClr val="accent1"/>
+          </a:fillRef>
+          <a:effectRef idx="2">
+            <a:schemeClr val="accent1"/>
+          </a:effectRef>
+          <a:fontRef idx="minor">
+            <a:schemeClr val="lt1"/>
+          </a:fontRef>
+        </p:style>
+        <p:txBody>
+          <a:bodyPr rtlCol="0" anchor="ctr"/>
+          <a:lstStyle/>
+          <a:p>
+            <a:pPr algn="ctr"/>
+          </a:p>
+        </p:txBody>
+      </p:sp>
+      <p:sp>
+        <p:nvSpPr>
+          <p:cNvPr id="26" name="TextBox 25"/>
+          <p:cNvSpPr txBox="1"/>
+          <p:nvPr/>
+        </p:nvSpPr>
+        <p:spPr>
+          <a:xfrm>
+            <a:off x="868680" y="4681728"/>
+            <a:ext cx="4846320" cy="411480"/>
+          </a:xfrm>
+          <a:prstGeom prst="rect">
+            <a:avLst/>
+          </a:prstGeom>
+          <a:noFill/>
+        </p:spPr>
+        <p:txBody>
+          <a:bodyPr wrap="square" anchor="ctr" lIns="0" rIns="0" tIns="0" bIns="0">
+            <a:spAutoFit/>
+          </a:bodyPr>
+          <a:lstStyle/>
+          <a:p>
+            <a:pPr algn="l"/>
+            <a:r>
+              <a:rPr sz="1500" b="1">
+                <a:solidFill>
+                  <a:srgbClr val="0F2A4C"/>
+                </a:solidFill>
+                <a:latin typeface="Calibri"/>
+              </a:rPr>
+              <a:t>Hourly Backups</a:t>
+            </a:r>
+          </a:p>
+        </p:txBody>
+      </p:sp>
+      <p:sp>
+        <p:nvSpPr>
+          <p:cNvPr id="27" name="TextBox 26"/>
+          <p:cNvSpPr txBox="1"/>
+          <p:nvPr/>
+        </p:nvSpPr>
+        <p:spPr>
+          <a:xfrm>
+            <a:off x="868680" y="5047488"/>
+            <a:ext cx="4846320" cy="365760"/>
+          </a:xfrm>
+          <a:prstGeom prst="rect">
+            <a:avLst/>
+          </a:prstGeom>
+          <a:noFill/>
+        </p:spPr>
+        <p:txBody>
+          <a:bodyPr wrap="square" anchor="t" lIns="0" rIns="0" tIns="0" bIns="0">
+            <a:spAutoFit/>
+          </a:bodyPr>
+          <a:lstStyle/>
+          <a:p>
+            <a:pPr algn="l">
+              <a:lnSpc>
+                <a:spcPct val="110000"/>
+              </a:lnSpc>
+            </a:pPr>
+            <a:r>
+              <a:rPr sz="1500" b="0">
+                <a:solidFill>
+                  <a:srgbClr val="243244"/>
+                </a:solidFill>
+                <a:latin typeface="Calibri"/>
+              </a:rPr>
+              <a:t>Automatic database backups with one-command restore.</a:t>
+            </a:r>
+          </a:p>
+        </p:txBody>
+      </p:sp>
+      <p:sp>
+        <p:nvSpPr>
+          <p:cNvPr id="28" name="Rounded Rectangle 27"/>
+          <p:cNvSpPr/>
+          <p:nvPr/>
+        </p:nvSpPr>
+        <p:spPr>
+          <a:xfrm>
+            <a:off x="6309360" y="4572000"/>
+            <a:ext cx="5303520" cy="914400"/>
+          </a:xfrm>
+          <a:prstGeom prst="roundRect">
+            <a:avLst/>
+          </a:prstGeom>
+          <a:solidFill>
+            <a:srgbClr val="FFFFFF"/>
+          </a:solidFill>
+          <a:ln>
+            <a:noFill/>
+          </a:ln>
+          <a:effectLst/>
+        </p:spPr>
+        <p:style>
+          <a:lnRef idx="1">
+            <a:schemeClr val="accent1"/>
+          </a:lnRef>
+          <a:fillRef idx="3">
+            <a:schemeClr val="accent1"/>
+          </a:fillRef>
+          <a:effectRef idx="2">
+            <a:schemeClr val="accent1"/>
+          </a:effectRef>
+          <a:fontRef idx="minor">
+            <a:schemeClr val="lt1"/>
+          </a:fontRef>
+        </p:style>
+        <p:txBody>
+          <a:bodyPr rtlCol="0" anchor="ctr"/>
+          <a:lstStyle/>
+          <a:p>
+            <a:pPr algn="ctr"/>
+          </a:p>
+        </p:txBody>
+      </p:sp>
+      <p:sp>
+        <p:nvSpPr>
+          <p:cNvPr id="29" name="Rectangle 28"/>
+          <p:cNvSpPr/>
+          <p:nvPr/>
+        </p:nvSpPr>
+        <p:spPr>
+          <a:xfrm>
+            <a:off x="6309360" y="4572000"/>
+            <a:ext cx="82296" cy="914400"/>
+          </a:xfrm>
+          <a:prstGeom prst="rect">
+            <a:avLst/>
+          </a:prstGeom>
+          <a:solidFill>
+            <a:srgbClr val="F2B418"/>
+          </a:solidFill>
+          <a:ln>
+            <a:noFill/>
+          </a:ln>
+          <a:effectLst/>
+        </p:spPr>
+        <p:style>
+          <a:lnRef idx="1">
+            <a:schemeClr val="accent1"/>
+          </a:lnRef>
+          <a:fillRef idx="3">
+            <a:schemeClr val="accent1"/>
+          </a:fillRef>
+          <a:effectRef idx="2">
+            <a:schemeClr val="accent1"/>
+          </a:effectRef>
+          <a:fontRef idx="minor">
+            <a:schemeClr val="lt1"/>
+          </a:fontRef>
+        </p:style>
+        <p:txBody>
+          <a:bodyPr rtlCol="0" anchor="ctr"/>
+          <a:lstStyle/>
+          <a:p>
+            <a:pPr algn="ctr"/>
+          </a:p>
+        </p:txBody>
+      </p:sp>
+      <p:sp>
+        <p:nvSpPr>
+          <p:cNvPr id="30" name="TextBox 29"/>
+          <p:cNvSpPr txBox="1"/>
+          <p:nvPr/>
+        </p:nvSpPr>
+        <p:spPr>
+          <a:xfrm>
+            <a:off x="6583680" y="4681728"/>
+            <a:ext cx="4846320" cy="411480"/>
+          </a:xfrm>
+          <a:prstGeom prst="rect">
+            <a:avLst/>
+          </a:prstGeom>
+          <a:noFill/>
+        </p:spPr>
+        <p:txBody>
+          <a:bodyPr wrap="square" anchor="ctr" lIns="0" rIns="0" tIns="0" bIns="0">
+            <a:spAutoFit/>
+          </a:bodyPr>
+          <a:lstStyle/>
+          <a:p>
+            <a:pPr algn="l"/>
+            <a:r>
+              <a:rPr sz="1500" b="1">
+                <a:solidFill>
+                  <a:srgbClr val="0F2A4C"/>
+                </a:solidFill>
+                <a:latin typeface="Calibri"/>
+              </a:rPr>
+              <a:t>Secure Remote Access</a:t>
+            </a:r>
+          </a:p>
+        </p:txBody>
+      </p:sp>
+      <p:sp>
+        <p:nvSpPr>
+          <p:cNvPr id="31" name="TextBox 30"/>
+          <p:cNvSpPr txBox="1"/>
+          <p:nvPr/>
+        </p:nvSpPr>
+        <p:spPr>
+          <a:xfrm>
+            <a:off x="6583680" y="5047488"/>
+            <a:ext cx="4846320" cy="365760"/>
+          </a:xfrm>
+          <a:prstGeom prst="rect">
+            <a:avLst/>
+          </a:prstGeom>
+          <a:noFill/>
+        </p:spPr>
+        <p:txBody>
+          <a:bodyPr wrap="square" anchor="t" lIns="0" rIns="0" tIns="0" bIns="0">
+            <a:spAutoFit/>
+          </a:bodyPr>
+          <a:lstStyle/>
+          <a:p>
+            <a:pPr algn="l">
+              <a:lnSpc>
+                <a:spcPct val="110000"/>
+              </a:lnSpc>
+            </a:pPr>
+            <a:r>
+              <a:rPr sz="1500" b="0">
+                <a:solidFill>
+                  <a:srgbClr val="243244"/>
+                </a:solidFill>
+                <a:latin typeface="Calibri"/>
+              </a:rPr>
+              <a:t>Tunnel lets officials sign in from outside the office.</a:t>
+            </a:r>
+          </a:p>
+        </p:txBody>
+      </p:sp>
+      <p:sp>
+        <p:nvSpPr>
+          <p:cNvPr id="32" name="Rounded Rectangle 31"/>
+          <p:cNvSpPr/>
+          <p:nvPr/>
+        </p:nvSpPr>
+        <p:spPr>
+          <a:xfrm>
+            <a:off x="594360" y="5623560"/>
+            <a:ext cx="5303520" cy="914400"/>
+          </a:xfrm>
+          <a:prstGeom prst="roundRect">
+            <a:avLst/>
+          </a:prstGeom>
+          <a:solidFill>
+            <a:srgbClr val="FFFFFF"/>
+          </a:solidFill>
+          <a:ln>
+            <a:noFill/>
+          </a:ln>
+          <a:effectLst/>
+        </p:spPr>
+        <p:style>
+          <a:lnRef idx="1">
+            <a:schemeClr val="accent1"/>
+          </a:lnRef>
+          <a:fillRef idx="3">
+            <a:schemeClr val="accent1"/>
+          </a:fillRef>
+          <a:effectRef idx="2">
+            <a:schemeClr val="accent1"/>
+          </a:effectRef>
+          <a:fontRef idx="minor">
+            <a:schemeClr val="lt1"/>
+          </a:fontRef>
+        </p:style>
+        <p:txBody>
+          <a:bodyPr rtlCol="0" anchor="ctr"/>
+          <a:lstStyle/>
+          <a:p>
+            <a:pPr algn="ctr"/>
+          </a:p>
+        </p:txBody>
+      </p:sp>
+      <p:sp>
+        <p:nvSpPr>
+          <p:cNvPr id="33" name="Rectangle 32"/>
+          <p:cNvSpPr/>
+          <p:nvPr/>
+        </p:nvSpPr>
+        <p:spPr>
+          <a:xfrm>
+            <a:off x="594360" y="5623560"/>
+            <a:ext cx="82296" cy="914400"/>
+          </a:xfrm>
+          <a:prstGeom prst="rect">
+            <a:avLst/>
+          </a:prstGeom>
+          <a:solidFill>
+            <a:srgbClr val="F2B418"/>
+          </a:solidFill>
+          <a:ln>
+            <a:noFill/>
+          </a:ln>
+          <a:effectLst/>
+        </p:spPr>
+        <p:style>
+          <a:lnRef idx="1">
+            <a:schemeClr val="accent1"/>
+          </a:lnRef>
+          <a:fillRef idx="3">
+            <a:schemeClr val="accent1"/>
+          </a:fillRef>
+          <a:effectRef idx="2">
+            <a:schemeClr val="accent1"/>
+          </a:effectRef>
+          <a:fontRef idx="minor">
+            <a:schemeClr val="lt1"/>
+          </a:fontRef>
+        </p:style>
+        <p:txBody>
+          <a:bodyPr rtlCol="0" anchor="ctr"/>
+          <a:lstStyle/>
+          <a:p>
+            <a:pPr algn="ctr"/>
+          </a:p>
+        </p:txBody>
+      </p:sp>
+      <p:sp>
+        <p:nvSpPr>
+          <p:cNvPr id="34" name="TextBox 33"/>
+          <p:cNvSpPr txBox="1"/>
+          <p:nvPr/>
+        </p:nvSpPr>
+        <p:spPr>
+          <a:xfrm>
+            <a:off x="868680" y="5733288"/>
+            <a:ext cx="4846320" cy="411480"/>
+          </a:xfrm>
+          <a:prstGeom prst="rect">
+            <a:avLst/>
+          </a:prstGeom>
+          <a:noFill/>
+        </p:spPr>
+        <p:txBody>
+          <a:bodyPr wrap="square" anchor="ctr" lIns="0" rIns="0" tIns="0" bIns="0">
+            <a:spAutoFit/>
+          </a:bodyPr>
+          <a:lstStyle/>
+          <a:p>
+            <a:pPr algn="l"/>
+            <a:r>
+              <a:rPr sz="1500" b="1">
+                <a:solidFill>
+                  <a:srgbClr val="0F2A4C"/>
+                </a:solidFill>
+                <a:latin typeface="Calibri"/>
+              </a:rPr>
+              <a:t>No External Dependencies</a:t>
+            </a:r>
+          </a:p>
+        </p:txBody>
+      </p:sp>
+      <p:sp>
+        <p:nvSpPr>
+          <p:cNvPr id="35" name="TextBox 34"/>
+          <p:cNvSpPr txBox="1"/>
+          <p:nvPr/>
+        </p:nvSpPr>
+        <p:spPr>
+          <a:xfrm>
+            <a:off x="868680" y="6099048"/>
+            <a:ext cx="4846320" cy="365760"/>
+          </a:xfrm>
+          <a:prstGeom prst="rect">
+            <a:avLst/>
+          </a:prstGeom>
+          <a:noFill/>
+        </p:spPr>
+        <p:txBody>
+          <a:bodyPr wrap="square" anchor="t" lIns="0" rIns="0" tIns="0" bIns="0">
+            <a:spAutoFit/>
+          </a:bodyPr>
+          <a:lstStyle/>
+          <a:p>
+            <a:pPr algn="l">
+              <a:lnSpc>
+                <a:spcPct val="110000"/>
+              </a:lnSpc>
+            </a:pPr>
+            <a:r>
+              <a:rPr sz="1500" b="0">
+                <a:solidFill>
+                  <a:srgbClr val="243244"/>
+                </a:solidFill>
+                <a:latin typeface="Calibri"/>
+              </a:rPr>
+              <a:t>No reliance on third-party accounts or cloud services.</a:t>
+            </a:r>
+          </a:p>
+        </p:txBody>
+      </p:sp>
+      <p:sp>
+        <p:nvSpPr>
+          <p:cNvPr id="36" name="Rounded Rectangle 35"/>
+          <p:cNvSpPr/>
+          <p:nvPr/>
+        </p:nvSpPr>
+        <p:spPr>
+          <a:xfrm>
+            <a:off x="6309360" y="5623560"/>
+            <a:ext cx="5303520" cy="914400"/>
+          </a:xfrm>
+          <a:prstGeom prst="roundRect">
+            <a:avLst/>
+          </a:prstGeom>
+          <a:solidFill>
+            <a:srgbClr val="FFFFFF"/>
+          </a:solidFill>
+          <a:ln>
+            <a:noFill/>
+          </a:ln>
+          <a:effectLst/>
+        </p:spPr>
+        <p:style>
+          <a:lnRef idx="1">
+            <a:schemeClr val="accent1"/>
+          </a:lnRef>
+          <a:fillRef idx="3">
+            <a:schemeClr val="accent1"/>
+          </a:fillRef>
+          <a:effectRef idx="2">
+            <a:schemeClr val="accent1"/>
+          </a:effectRef>
+          <a:fontRef idx="minor">
+            <a:schemeClr val="lt1"/>
+          </a:fontRef>
+        </p:style>
+        <p:txBody>
+          <a:bodyPr rtlCol="0" anchor="ctr"/>
+          <a:lstStyle/>
+          <a:p>
+            <a:pPr algn="ctr"/>
+          </a:p>
+        </p:txBody>
+      </p:sp>
+      <p:sp>
+        <p:nvSpPr>
+          <p:cNvPr id="37" name="Rectangle 36"/>
+          <p:cNvSpPr/>
+          <p:nvPr/>
+        </p:nvSpPr>
+        <p:spPr>
+          <a:xfrm>
+            <a:off x="6309360" y="5623560"/>
+            <a:ext cx="82296" cy="914400"/>
+          </a:xfrm>
+          <a:prstGeom prst="rect">
+            <a:avLst/>
+          </a:prstGeom>
+          <a:solidFill>
+            <a:srgbClr val="F2B418"/>
+          </a:solidFill>
+          <a:ln>
+            <a:noFill/>
+          </a:ln>
+          <a:effectLst/>
+        </p:spPr>
+        <p:style>
+          <a:lnRef idx="1">
+            <a:schemeClr val="accent1"/>
+          </a:lnRef>
+          <a:fillRef idx="3">
+            <a:schemeClr val="accent1"/>
+          </a:fillRef>
+          <a:effectRef idx="2">
+            <a:schemeClr val="accent1"/>
+          </a:effectRef>
+          <a:fontRef idx="minor">
+            <a:schemeClr val="lt1"/>
+          </a:fontRef>
+        </p:style>
+        <p:txBody>
+          <a:bodyPr rtlCol="0" anchor="ctr"/>
+          <a:lstStyle/>
+          <a:p>
+            <a:pPr algn="ctr"/>
+          </a:p>
+        </p:txBody>
+      </p:sp>
+      <p:sp>
+        <p:nvSpPr>
+          <p:cNvPr id="38" name="TextBox 37"/>
+          <p:cNvSpPr txBox="1"/>
+          <p:nvPr/>
+        </p:nvSpPr>
+        <p:spPr>
+          <a:xfrm>
+            <a:off x="6583680" y="5733288"/>
+            <a:ext cx="4846320" cy="411480"/>
+          </a:xfrm>
+          <a:prstGeom prst="rect">
+            <a:avLst/>
+          </a:prstGeom>
+          <a:noFill/>
+        </p:spPr>
+        <p:txBody>
+          <a:bodyPr wrap="square" anchor="ctr" lIns="0" rIns="0" tIns="0" bIns="0">
+            <a:spAutoFit/>
+          </a:bodyPr>
+          <a:lstStyle/>
+          <a:p>
+            <a:pPr algn="l"/>
+            <a:r>
+              <a:rPr sz="1500" b="1">
+                <a:solidFill>
+                  <a:srgbClr val="0F2A4C"/>
+                </a:solidFill>
+                <a:latin typeface="Calibri"/>
+              </a:rPr>
+              <a:t>Stop and Start on Demand</a:t>
+            </a:r>
+          </a:p>
+        </p:txBody>
+      </p:sp>
+      <p:sp>
+        <p:nvSpPr>
+          <p:cNvPr id="39" name="TextBox 38"/>
+          <p:cNvSpPr txBox="1"/>
+          <p:nvPr/>
+        </p:nvSpPr>
+        <p:spPr>
+          <a:xfrm>
+            <a:off x="6583680" y="6099048"/>
+            <a:ext cx="4846320" cy="365760"/>
+          </a:xfrm>
+          <a:prstGeom prst="rect">
+            <a:avLst/>
+          </a:prstGeom>
+          <a:noFill/>
+        </p:spPr>
+        <p:txBody>
+          <a:bodyPr wrap="square" anchor="t" lIns="0" rIns="0" tIns="0" bIns="0">
+            <a:spAutoFit/>
+          </a:bodyPr>
+          <a:lstStyle/>
+          <a:p>
+            <a:pPr algn="l">
+              <a:lnSpc>
+                <a:spcPct val="110000"/>
+              </a:lnSpc>
+            </a:pPr>
+            <a:r>
+              <a:rPr sz="1500" b="0">
+                <a:solidFill>
+                  <a:srgbClr val="243244"/>
+                </a:solidFill>
+                <a:latin typeface="Calibri"/>
+              </a:rPr>
+              <a:t>One command shuts down; one command starts it back up.</a:t>
+            </a:r>
+          </a:p>
+        </p:txBody>
+      </p:sp>
+    </p:spTree>
+  </p:cSld>
+  <p:clrMapOvr>
+    <a:masterClrMapping/>
+  </p:clrMapOvr>
+</p:sld>
+</file>
+
 <file path=ppt/slides/slide2.xml><?xml version="1.0" encoding="utf-8"?>
 <p:sld xmlns:a="http://schemas.openxmlformats.org/drawingml/2006/main" xmlns:p="http://schemas.openxmlformats.org/presentationml/2006/main" xmlns:r="http://schemas.openxmlformats.org/officeDocument/2006/relationships">
   <p:cSld>
@@ -4820,7 +6373,7 @@
                 </a:solidFill>
                 <a:latin typeface="Calibri"/>
               </a:rPr>
-              <a:t>Role-based access, row-level security and full audit trails.</a:t>
+              <a:t>Role-based access, per-user data scoping and full audit trails.</a:t>
             </a:r>
           </a:p>
         </p:txBody>
@@ -6047,7 +7600,7 @@
                 </a:solidFill>
                 <a:latin typeface="Calibri"/>
               </a:rPr>
-              <a:t>Publish announcements with attachments and notify residents.</a:t>
+              <a:t>Publish announcements with attachments; in-app notification plus queued email.</a:t>
             </a:r>
           </a:p>
         </p:txBody>
@@ -6547,7 +8100,7 @@
                 </a:solidFill>
                 <a:latin typeface="Calibri"/>
               </a:rPr>
-              <a:t>Self-service for every resident</a:t>
+              <a:t>Accounts issued by the Barangay Office</a:t>
             </a:r>
           </a:p>
         </p:txBody>
@@ -6788,7 +8341,7 @@
                 </a:solidFill>
                 <a:latin typeface="Calibri"/>
               </a:rPr>
-              <a:t>Self-service personal information management.</a:t>
+              <a:t>Manage your own profile anytime after signing in.</a:t>
             </a:r>
           </a:p>
         </p:txBody>
@@ -7598,7 +9151,7 @@
                 </a:solidFill>
                 <a:latin typeface="Calibri"/>
               </a:rPr>
-              <a:t>Real-time alerts for every activity.</a:t>
+              <a:t>In-app alerts for every activity, plus optional queued email.</a:t>
             </a:r>
           </a:p>
         </p:txBody>
@@ -8138,7 +9691,7 @@
                 </a:solidFill>
                 <a:latin typeface="Calibri"/>
               </a:rPr>
-              <a:t>Row-Level Security</a:t>
+              <a:t>Auto-Scoped Access</a:t>
             </a:r>
           </a:p>
         </p:txBody>
@@ -8177,7 +9730,7 @@
                 </a:solidFill>
                 <a:latin typeface="Calibri"/>
               </a:rPr>
-              <a:t>Database RLS policies protect every table and record.</a:t>
+              <a:t>Resident reads and writes are scoped to their own records.</a:t>
             </a:r>
           </a:p>
         </p:txBody>
@@ -8462,7 +10015,7 @@
                 </a:solidFill>
                 <a:latin typeface="Calibri"/>
               </a:rPr>
-              <a:t>Secure Storage</a:t>
+              <a:t>Hardened Auth and Storage</a:t>
             </a:r>
           </a:p>
         </p:txBody>
@@ -8501,7 +10054,7 @@
                 </a:solidFill>
                 <a:latin typeface="Calibri"/>
               </a:rPr>
-              <a:t>Protected buckets for documents and photos with file validation.</a:t>
+              <a:t>bcrypt, HttpOnly sessions, 5-try lockout, default passwords refused; per-resident validated uploads.</a:t>
             </a:r>
           </a:p>
         </p:txBody>
@@ -9357,7 +10910,7 @@
                 </a:solidFill>
                 <a:latin typeface="Calibri"/>
               </a:rPr>
-              <a:t>Supabase Auth · Row-Level Security · RBAC</a:t>
+              <a:t>Local auth · bcrypt · HttpOnly sessions · RBAC</a:t>
             </a:r>
           </a:p>
         </p:txBody>
@@ -9519,7 +11072,7 @@
                 </a:solidFill>
                 <a:latin typeface="Calibri"/>
               </a:rPr>
-              <a:t>Supabase PostgreSQL with full RLS</a:t>
+              <a:t>PostgreSQL, self-hosted on-premise</a:t>
             </a:r>
           </a:p>
         </p:txBody>
@@ -10271,6 +11824,1233 @@
                 <a:latin typeface="Calibri"/>
               </a:rPr>
               <a:t>BarangayConnect · Digital Governance, Made Simple</a:t>
+            </a:r>
+          </a:p>
+        </p:txBody>
+      </p:sp>
+    </p:spTree>
+  </p:cSld>
+  <p:clrMapOvr>
+    <a:masterClrMapping/>
+  </p:clrMapOvr>
+</p:sld>
+</file>
+
+<file path=ppt/slides/slide9.xml><?xml version="1.0" encoding="utf-8"?>
+<p:sld xmlns:a="http://schemas.openxmlformats.org/drawingml/2006/main" xmlns:p="http://schemas.openxmlformats.org/presentationml/2006/main" xmlns:r="http://schemas.openxmlformats.org/officeDocument/2006/relationships">
+  <p:cSld>
+    <p:spTree>
+      <p:nvGrpSpPr>
+        <p:cNvPr id="1" name=""/>
+        <p:cNvGrpSpPr/>
+        <p:nvPr/>
+      </p:nvGrpSpPr>
+      <p:grpSpPr/>
+      <p:sp>
+        <p:nvSpPr>
+          <p:cNvPr id="2" name="Rectangle 1"/>
+          <p:cNvSpPr/>
+          <p:nvPr/>
+        </p:nvSpPr>
+        <p:spPr>
+          <a:xfrm>
+            <a:off x="0" y="0"/>
+            <a:ext cx="12191695" cy="1234440"/>
+          </a:xfrm>
+          <a:prstGeom prst="rect">
+            <a:avLst/>
+          </a:prstGeom>
+          <a:solidFill>
+            <a:srgbClr val="0F2A4C"/>
+          </a:solidFill>
+          <a:ln>
+            <a:noFill/>
+          </a:ln>
+          <a:effectLst/>
+        </p:spPr>
+        <p:style>
+          <a:lnRef idx="1">
+            <a:schemeClr val="accent1"/>
+          </a:lnRef>
+          <a:fillRef idx="3">
+            <a:schemeClr val="accent1"/>
+          </a:fillRef>
+          <a:effectRef idx="2">
+            <a:schemeClr val="accent1"/>
+          </a:effectRef>
+          <a:fontRef idx="minor">
+            <a:schemeClr val="lt1"/>
+          </a:fontRef>
+        </p:style>
+        <p:txBody>
+          <a:bodyPr rtlCol="0" anchor="ctr"/>
+          <a:lstStyle/>
+          <a:p>
+            <a:pPr algn="ctr"/>
+          </a:p>
+        </p:txBody>
+      </p:sp>
+      <p:sp>
+        <p:nvSpPr>
+          <p:cNvPr id="3" name="Rectangle 2"/>
+          <p:cNvSpPr/>
+          <p:nvPr/>
+        </p:nvSpPr>
+        <p:spPr>
+          <a:xfrm>
+            <a:off x="0" y="1234440"/>
+            <a:ext cx="12191695" cy="50800"/>
+          </a:xfrm>
+          <a:prstGeom prst="rect">
+            <a:avLst/>
+          </a:prstGeom>
+          <a:solidFill>
+            <a:srgbClr val="F2B418"/>
+          </a:solidFill>
+          <a:ln>
+            <a:noFill/>
+          </a:ln>
+          <a:effectLst/>
+        </p:spPr>
+        <p:style>
+          <a:lnRef idx="1">
+            <a:schemeClr val="accent1"/>
+          </a:lnRef>
+          <a:fillRef idx="3">
+            <a:schemeClr val="accent1"/>
+          </a:fillRef>
+          <a:effectRef idx="2">
+            <a:schemeClr val="accent1"/>
+          </a:effectRef>
+          <a:fontRef idx="minor">
+            <a:schemeClr val="lt1"/>
+          </a:fontRef>
+        </p:style>
+        <p:txBody>
+          <a:bodyPr rtlCol="0" anchor="ctr"/>
+          <a:lstStyle/>
+          <a:p>
+            <a:pPr algn="ctr"/>
+          </a:p>
+        </p:txBody>
+      </p:sp>
+      <p:sp>
+        <p:nvSpPr>
+          <p:cNvPr id="4" name="TextBox 3"/>
+          <p:cNvSpPr txBox="1"/>
+          <p:nvPr/>
+        </p:nvSpPr>
+        <p:spPr>
+          <a:xfrm>
+            <a:off x="640080" y="0"/>
+            <a:ext cx="8686800" cy="1234440"/>
+          </a:xfrm>
+          <a:prstGeom prst="rect">
+            <a:avLst/>
+          </a:prstGeom>
+          <a:noFill/>
+        </p:spPr>
+        <p:txBody>
+          <a:bodyPr wrap="square" anchor="ctr" lIns="0" rIns="0" tIns="0" bIns="0">
+            <a:spAutoFit/>
+          </a:bodyPr>
+          <a:lstStyle/>
+          <a:p>
+            <a:pPr algn="l"/>
+            <a:r>
+              <a:rPr sz="3000" b="1">
+                <a:solidFill>
+                  <a:srgbClr val="FFFFFF"/>
+                </a:solidFill>
+                <a:latin typeface="Calibri"/>
+              </a:rPr>
+              <a:t>Accounts &amp; Access</a:t>
+            </a:r>
+          </a:p>
+        </p:txBody>
+      </p:sp>
+      <p:sp>
+        <p:nvSpPr>
+          <p:cNvPr id="5" name="TextBox 4"/>
+          <p:cNvSpPr txBox="1"/>
+          <p:nvPr/>
+        </p:nvSpPr>
+        <p:spPr>
+          <a:xfrm>
+            <a:off x="8778240" y="0"/>
+            <a:ext cx="2834640" cy="1234440"/>
+          </a:xfrm>
+          <a:prstGeom prst="rect">
+            <a:avLst/>
+          </a:prstGeom>
+          <a:noFill/>
+        </p:spPr>
+        <p:txBody>
+          <a:bodyPr wrap="square" anchor="ctr" lIns="0" rIns="0" tIns="0" bIns="0">
+            <a:spAutoFit/>
+          </a:bodyPr>
+          <a:lstStyle/>
+          <a:p>
+            <a:pPr algn="r"/>
+            <a:r>
+              <a:rPr sz="1200" b="0">
+                <a:solidFill>
+                  <a:srgbClr val="C9D6E8"/>
+                </a:solidFill>
+                <a:latin typeface="Calibri"/>
+              </a:rPr>
+              <a:t>Barangay-issued logins, no public signup</a:t>
+            </a:r>
+          </a:p>
+        </p:txBody>
+      </p:sp>
+      <p:sp>
+        <p:nvSpPr>
+          <p:cNvPr id="6" name="Rectangle 5"/>
+          <p:cNvSpPr/>
+          <p:nvPr/>
+        </p:nvSpPr>
+        <p:spPr>
+          <a:xfrm>
+            <a:off x="11231575" y="0"/>
+            <a:ext cx="960120" cy="384048"/>
+          </a:xfrm>
+          <a:prstGeom prst="rect">
+            <a:avLst/>
+          </a:prstGeom>
+          <a:solidFill>
+            <a:srgbClr val="F2B418"/>
+          </a:solidFill>
+          <a:ln>
+            <a:noFill/>
+          </a:ln>
+          <a:effectLst/>
+        </p:spPr>
+        <p:style>
+          <a:lnRef idx="1">
+            <a:schemeClr val="accent1"/>
+          </a:lnRef>
+          <a:fillRef idx="3">
+            <a:schemeClr val="accent1"/>
+          </a:fillRef>
+          <a:effectRef idx="2">
+            <a:schemeClr val="accent1"/>
+          </a:effectRef>
+          <a:fontRef idx="minor">
+            <a:schemeClr val="lt1"/>
+          </a:fontRef>
+        </p:style>
+        <p:txBody>
+          <a:bodyPr rtlCol="0" anchor="ctr"/>
+          <a:lstStyle/>
+          <a:p>
+            <a:pPr algn="ctr"/>
+          </a:p>
+        </p:txBody>
+      </p:sp>
+      <p:sp>
+        <p:nvSpPr>
+          <p:cNvPr id="7" name="TextBox 6"/>
+          <p:cNvSpPr txBox="1"/>
+          <p:nvPr/>
+        </p:nvSpPr>
+        <p:spPr>
+          <a:xfrm>
+            <a:off x="11231575" y="0"/>
+            <a:ext cx="960120" cy="384048"/>
+          </a:xfrm>
+          <a:prstGeom prst="rect">
+            <a:avLst/>
+          </a:prstGeom>
+          <a:noFill/>
+        </p:spPr>
+        <p:txBody>
+          <a:bodyPr wrap="square" anchor="ctr" lIns="0" rIns="0" tIns="0" bIns="0">
+            <a:spAutoFit/>
+          </a:bodyPr>
+          <a:lstStyle/>
+          <a:p>
+            <a:pPr algn="ctr"/>
+            <a:r>
+              <a:rPr sz="1400" b="1">
+                <a:solidFill>
+                  <a:srgbClr val="0F2A4C"/>
+                </a:solidFill>
+                <a:latin typeface="Calibri"/>
+              </a:rPr>
+              <a:t>BC</a:t>
+            </a:r>
+          </a:p>
+        </p:txBody>
+      </p:sp>
+      <p:sp>
+        <p:nvSpPr>
+          <p:cNvPr id="8" name="Rounded Rectangle 7"/>
+          <p:cNvSpPr/>
+          <p:nvPr/>
+        </p:nvSpPr>
+        <p:spPr>
+          <a:xfrm>
+            <a:off x="731520" y="1645920"/>
+            <a:ext cx="3291840" cy="1920240"/>
+          </a:xfrm>
+          <a:prstGeom prst="roundRect">
+            <a:avLst/>
+          </a:prstGeom>
+          <a:solidFill>
+            <a:srgbClr val="FFFFFF"/>
+          </a:solidFill>
+          <a:ln>
+            <a:noFill/>
+          </a:ln>
+          <a:effectLst/>
+        </p:spPr>
+        <p:style>
+          <a:lnRef idx="1">
+            <a:schemeClr val="accent1"/>
+          </a:lnRef>
+          <a:fillRef idx="3">
+            <a:schemeClr val="accent1"/>
+          </a:fillRef>
+          <a:effectRef idx="2">
+            <a:schemeClr val="accent1"/>
+          </a:effectRef>
+          <a:fontRef idx="minor">
+            <a:schemeClr val="lt1"/>
+          </a:fontRef>
+        </p:style>
+        <p:txBody>
+          <a:bodyPr rtlCol="0" anchor="ctr"/>
+          <a:lstStyle/>
+          <a:p>
+            <a:pPr algn="ctr"/>
+          </a:p>
+        </p:txBody>
+      </p:sp>
+      <p:sp>
+        <p:nvSpPr>
+          <p:cNvPr id="9" name="Rectangle 8"/>
+          <p:cNvSpPr/>
+          <p:nvPr/>
+        </p:nvSpPr>
+        <p:spPr>
+          <a:xfrm>
+            <a:off x="731520" y="1645920"/>
+            <a:ext cx="82296" cy="1920240"/>
+          </a:xfrm>
+          <a:prstGeom prst="rect">
+            <a:avLst/>
+          </a:prstGeom>
+          <a:solidFill>
+            <a:srgbClr val="F2B418"/>
+          </a:solidFill>
+          <a:ln>
+            <a:noFill/>
+          </a:ln>
+          <a:effectLst/>
+        </p:spPr>
+        <p:style>
+          <a:lnRef idx="1">
+            <a:schemeClr val="accent1"/>
+          </a:lnRef>
+          <a:fillRef idx="3">
+            <a:schemeClr val="accent1"/>
+          </a:fillRef>
+          <a:effectRef idx="2">
+            <a:schemeClr val="accent1"/>
+          </a:effectRef>
+          <a:fontRef idx="minor">
+            <a:schemeClr val="lt1"/>
+          </a:fontRef>
+        </p:style>
+        <p:txBody>
+          <a:bodyPr rtlCol="0" anchor="ctr"/>
+          <a:lstStyle/>
+          <a:p>
+            <a:pPr algn="ctr"/>
+          </a:p>
+        </p:txBody>
+      </p:sp>
+      <p:sp>
+        <p:nvSpPr>
+          <p:cNvPr id="10" name="TextBox 9"/>
+          <p:cNvSpPr txBox="1"/>
+          <p:nvPr/>
+        </p:nvSpPr>
+        <p:spPr>
+          <a:xfrm>
+            <a:off x="1005840" y="1755648"/>
+            <a:ext cx="2834640" cy="411480"/>
+          </a:xfrm>
+          <a:prstGeom prst="rect">
+            <a:avLst/>
+          </a:prstGeom>
+          <a:noFill/>
+        </p:spPr>
+        <p:txBody>
+          <a:bodyPr wrap="square" anchor="ctr" lIns="0" rIns="0" tIns="0" bIns="0">
+            <a:spAutoFit/>
+          </a:bodyPr>
+          <a:lstStyle/>
+          <a:p>
+            <a:pPr algn="l"/>
+            <a:r>
+              <a:rPr sz="1500" b="1">
+                <a:solidFill>
+                  <a:srgbClr val="0F2A4C"/>
+                </a:solidFill>
+                <a:latin typeface="Calibri"/>
+              </a:rPr>
+              <a:t>Barangay-Issued Accounts</a:t>
+            </a:r>
+          </a:p>
+        </p:txBody>
+      </p:sp>
+      <p:sp>
+        <p:nvSpPr>
+          <p:cNvPr id="11" name="TextBox 10"/>
+          <p:cNvSpPr txBox="1"/>
+          <p:nvPr/>
+        </p:nvSpPr>
+        <p:spPr>
+          <a:xfrm>
+            <a:off x="1005840" y="2121408"/>
+            <a:ext cx="2834640" cy="1371600"/>
+          </a:xfrm>
+          <a:prstGeom prst="rect">
+            <a:avLst/>
+          </a:prstGeom>
+          <a:noFill/>
+        </p:spPr>
+        <p:txBody>
+          <a:bodyPr wrap="square" anchor="t" lIns="0" rIns="0" tIns="0" bIns="0">
+            <a:spAutoFit/>
+          </a:bodyPr>
+          <a:lstStyle/>
+          <a:p>
+            <a:pPr algn="l">
+              <a:lnSpc>
+                <a:spcPct val="110000"/>
+              </a:lnSpc>
+            </a:pPr>
+            <a:r>
+              <a:rPr sz="1500" b="0">
+                <a:solidFill>
+                  <a:srgbClr val="243244"/>
+                </a:solidFill>
+                <a:latin typeface="Calibri"/>
+              </a:rPr>
+              <a:t>Office creates resident login accounts inside the Residents module.</a:t>
+            </a:r>
+          </a:p>
+        </p:txBody>
+      </p:sp>
+      <p:sp>
+        <p:nvSpPr>
+          <p:cNvPr id="12" name="Rounded Rectangle 11"/>
+          <p:cNvSpPr/>
+          <p:nvPr/>
+        </p:nvSpPr>
+        <p:spPr>
+          <a:xfrm>
+            <a:off x="4343400" y="1645920"/>
+            <a:ext cx="3291840" cy="1920240"/>
+          </a:xfrm>
+          <a:prstGeom prst="roundRect">
+            <a:avLst/>
+          </a:prstGeom>
+          <a:solidFill>
+            <a:srgbClr val="FFFFFF"/>
+          </a:solidFill>
+          <a:ln>
+            <a:noFill/>
+          </a:ln>
+          <a:effectLst/>
+        </p:spPr>
+        <p:style>
+          <a:lnRef idx="1">
+            <a:schemeClr val="accent1"/>
+          </a:lnRef>
+          <a:fillRef idx="3">
+            <a:schemeClr val="accent1"/>
+          </a:fillRef>
+          <a:effectRef idx="2">
+            <a:schemeClr val="accent1"/>
+          </a:effectRef>
+          <a:fontRef idx="minor">
+            <a:schemeClr val="lt1"/>
+          </a:fontRef>
+        </p:style>
+        <p:txBody>
+          <a:bodyPr rtlCol="0" anchor="ctr"/>
+          <a:lstStyle/>
+          <a:p>
+            <a:pPr algn="ctr"/>
+          </a:p>
+        </p:txBody>
+      </p:sp>
+      <p:sp>
+        <p:nvSpPr>
+          <p:cNvPr id="13" name="Rectangle 12"/>
+          <p:cNvSpPr/>
+          <p:nvPr/>
+        </p:nvSpPr>
+        <p:spPr>
+          <a:xfrm>
+            <a:off x="4343400" y="1645920"/>
+            <a:ext cx="82296" cy="1920240"/>
+          </a:xfrm>
+          <a:prstGeom prst="rect">
+            <a:avLst/>
+          </a:prstGeom>
+          <a:solidFill>
+            <a:srgbClr val="F2B418"/>
+          </a:solidFill>
+          <a:ln>
+            <a:noFill/>
+          </a:ln>
+          <a:effectLst/>
+        </p:spPr>
+        <p:style>
+          <a:lnRef idx="1">
+            <a:schemeClr val="accent1"/>
+          </a:lnRef>
+          <a:fillRef idx="3">
+            <a:schemeClr val="accent1"/>
+          </a:fillRef>
+          <a:effectRef idx="2">
+            <a:schemeClr val="accent1"/>
+          </a:effectRef>
+          <a:fontRef idx="minor">
+            <a:schemeClr val="lt1"/>
+          </a:fontRef>
+        </p:style>
+        <p:txBody>
+          <a:bodyPr rtlCol="0" anchor="ctr"/>
+          <a:lstStyle/>
+          <a:p>
+            <a:pPr algn="ctr"/>
+          </a:p>
+        </p:txBody>
+      </p:sp>
+      <p:sp>
+        <p:nvSpPr>
+          <p:cNvPr id="14" name="TextBox 13"/>
+          <p:cNvSpPr txBox="1"/>
+          <p:nvPr/>
+        </p:nvSpPr>
+        <p:spPr>
+          <a:xfrm>
+            <a:off x="4617720" y="1755648"/>
+            <a:ext cx="2834640" cy="411480"/>
+          </a:xfrm>
+          <a:prstGeom prst="rect">
+            <a:avLst/>
+          </a:prstGeom>
+          <a:noFill/>
+        </p:spPr>
+        <p:txBody>
+          <a:bodyPr wrap="square" anchor="ctr" lIns="0" rIns="0" tIns="0" bIns="0">
+            <a:spAutoFit/>
+          </a:bodyPr>
+          <a:lstStyle/>
+          <a:p>
+            <a:pPr algn="l"/>
+            <a:r>
+              <a:rPr sz="1500" b="1">
+                <a:solidFill>
+                  <a:srgbClr val="0F2A4C"/>
+                </a:solidFill>
+                <a:latin typeface="Calibri"/>
+              </a:rPr>
+              <a:t>Add Resident / Create Login</a:t>
+            </a:r>
+          </a:p>
+        </p:txBody>
+      </p:sp>
+      <p:sp>
+        <p:nvSpPr>
+          <p:cNvPr id="15" name="TextBox 14"/>
+          <p:cNvSpPr txBox="1"/>
+          <p:nvPr/>
+        </p:nvSpPr>
+        <p:spPr>
+          <a:xfrm>
+            <a:off x="4617720" y="2121408"/>
+            <a:ext cx="2834640" cy="1371600"/>
+          </a:xfrm>
+          <a:prstGeom prst="rect">
+            <a:avLst/>
+          </a:prstGeom>
+          <a:noFill/>
+        </p:spPr>
+        <p:txBody>
+          <a:bodyPr wrap="square" anchor="t" lIns="0" rIns="0" tIns="0" bIns="0">
+            <a:spAutoFit/>
+          </a:bodyPr>
+          <a:lstStyle/>
+          <a:p>
+            <a:pPr algn="l">
+              <a:lnSpc>
+                <a:spcPct val="110000"/>
+              </a:lnSpc>
+            </a:pPr>
+            <a:r>
+              <a:rPr sz="1500" b="0">
+                <a:solidFill>
+                  <a:srgbClr val="243244"/>
+                </a:solidFill>
+                <a:latin typeface="Calibri"/>
+              </a:rPr>
+              <a:t>Two entry points: new households or existing residents.</a:t>
+            </a:r>
+          </a:p>
+        </p:txBody>
+      </p:sp>
+      <p:sp>
+        <p:nvSpPr>
+          <p:cNvPr id="16" name="Rounded Rectangle 15"/>
+          <p:cNvSpPr/>
+          <p:nvPr/>
+        </p:nvSpPr>
+        <p:spPr>
+          <a:xfrm>
+            <a:off x="7955279" y="1645920"/>
+            <a:ext cx="3291840" cy="1920240"/>
+          </a:xfrm>
+          <a:prstGeom prst="roundRect">
+            <a:avLst/>
+          </a:prstGeom>
+          <a:solidFill>
+            <a:srgbClr val="FFFFFF"/>
+          </a:solidFill>
+          <a:ln>
+            <a:noFill/>
+          </a:ln>
+          <a:effectLst/>
+        </p:spPr>
+        <p:style>
+          <a:lnRef idx="1">
+            <a:schemeClr val="accent1"/>
+          </a:lnRef>
+          <a:fillRef idx="3">
+            <a:schemeClr val="accent1"/>
+          </a:fillRef>
+          <a:effectRef idx="2">
+            <a:schemeClr val="accent1"/>
+          </a:effectRef>
+          <a:fontRef idx="minor">
+            <a:schemeClr val="lt1"/>
+          </a:fontRef>
+        </p:style>
+        <p:txBody>
+          <a:bodyPr rtlCol="0" anchor="ctr"/>
+          <a:lstStyle/>
+          <a:p>
+            <a:pPr algn="ctr"/>
+          </a:p>
+        </p:txBody>
+      </p:sp>
+      <p:sp>
+        <p:nvSpPr>
+          <p:cNvPr id="17" name="Rectangle 16"/>
+          <p:cNvSpPr/>
+          <p:nvPr/>
+        </p:nvSpPr>
+        <p:spPr>
+          <a:xfrm>
+            <a:off x="7955279" y="1645920"/>
+            <a:ext cx="82296" cy="1920240"/>
+          </a:xfrm>
+          <a:prstGeom prst="rect">
+            <a:avLst/>
+          </a:prstGeom>
+          <a:solidFill>
+            <a:srgbClr val="F2B418"/>
+          </a:solidFill>
+          <a:ln>
+            <a:noFill/>
+          </a:ln>
+          <a:effectLst/>
+        </p:spPr>
+        <p:style>
+          <a:lnRef idx="1">
+            <a:schemeClr val="accent1"/>
+          </a:lnRef>
+          <a:fillRef idx="3">
+            <a:schemeClr val="accent1"/>
+          </a:fillRef>
+          <a:effectRef idx="2">
+            <a:schemeClr val="accent1"/>
+          </a:effectRef>
+          <a:fontRef idx="minor">
+            <a:schemeClr val="lt1"/>
+          </a:fontRef>
+        </p:style>
+        <p:txBody>
+          <a:bodyPr rtlCol="0" anchor="ctr"/>
+          <a:lstStyle/>
+          <a:p>
+            <a:pPr algn="ctr"/>
+          </a:p>
+        </p:txBody>
+      </p:sp>
+      <p:sp>
+        <p:nvSpPr>
+          <p:cNvPr id="18" name="TextBox 17"/>
+          <p:cNvSpPr txBox="1"/>
+          <p:nvPr/>
+        </p:nvSpPr>
+        <p:spPr>
+          <a:xfrm>
+            <a:off x="8229599" y="1755648"/>
+            <a:ext cx="2834640" cy="411480"/>
+          </a:xfrm>
+          <a:prstGeom prst="rect">
+            <a:avLst/>
+          </a:prstGeom>
+          <a:noFill/>
+        </p:spPr>
+        <p:txBody>
+          <a:bodyPr wrap="square" anchor="ctr" lIns="0" rIns="0" tIns="0" bIns="0">
+            <a:spAutoFit/>
+          </a:bodyPr>
+          <a:lstStyle/>
+          <a:p>
+            <a:pPr algn="l"/>
+            <a:r>
+              <a:rPr sz="1500" b="1">
+                <a:solidFill>
+                  <a:srgbClr val="0F2A4C"/>
+                </a:solidFill>
+                <a:latin typeface="Calibri"/>
+              </a:rPr>
+              <a:t>Office-Controlled Passwords</a:t>
+            </a:r>
+          </a:p>
+        </p:txBody>
+      </p:sp>
+      <p:sp>
+        <p:nvSpPr>
+          <p:cNvPr id="19" name="TextBox 18"/>
+          <p:cNvSpPr txBox="1"/>
+          <p:nvPr/>
+        </p:nvSpPr>
+        <p:spPr>
+          <a:xfrm>
+            <a:off x="8229599" y="2121408"/>
+            <a:ext cx="2834640" cy="1371600"/>
+          </a:xfrm>
+          <a:prstGeom prst="rect">
+            <a:avLst/>
+          </a:prstGeom>
+          <a:noFill/>
+        </p:spPr>
+        <p:txBody>
+          <a:bodyPr wrap="square" anchor="t" lIns="0" rIns="0" tIns="0" bIns="0">
+            <a:spAutoFit/>
+          </a:bodyPr>
+          <a:lstStyle/>
+          <a:p>
+            <a:pPr algn="l">
+              <a:lnSpc>
+                <a:spcPct val="110000"/>
+              </a:lnSpc>
+            </a:pPr>
+            <a:r>
+              <a:rPr sz="1500" b="0">
+                <a:solidFill>
+                  <a:srgbClr val="243244"/>
+                </a:solidFill>
+                <a:latin typeface="Calibri"/>
+              </a:rPr>
+              <a:t>Admin sets the initial password for each resident account.</a:t>
+            </a:r>
+          </a:p>
+        </p:txBody>
+      </p:sp>
+      <p:sp>
+        <p:nvSpPr>
+          <p:cNvPr id="20" name="Rounded Rectangle 19"/>
+          <p:cNvSpPr/>
+          <p:nvPr/>
+        </p:nvSpPr>
+        <p:spPr>
+          <a:xfrm>
+            <a:off x="731520" y="4206240"/>
+            <a:ext cx="3291840" cy="1920240"/>
+          </a:xfrm>
+          <a:prstGeom prst="roundRect">
+            <a:avLst/>
+          </a:prstGeom>
+          <a:solidFill>
+            <a:srgbClr val="FFFFFF"/>
+          </a:solidFill>
+          <a:ln>
+            <a:noFill/>
+          </a:ln>
+          <a:effectLst/>
+        </p:spPr>
+        <p:style>
+          <a:lnRef idx="1">
+            <a:schemeClr val="accent1"/>
+          </a:lnRef>
+          <a:fillRef idx="3">
+            <a:schemeClr val="accent1"/>
+          </a:fillRef>
+          <a:effectRef idx="2">
+            <a:schemeClr val="accent1"/>
+          </a:effectRef>
+          <a:fontRef idx="minor">
+            <a:schemeClr val="lt1"/>
+          </a:fontRef>
+        </p:style>
+        <p:txBody>
+          <a:bodyPr rtlCol="0" anchor="ctr"/>
+          <a:lstStyle/>
+          <a:p>
+            <a:pPr algn="ctr"/>
+          </a:p>
+        </p:txBody>
+      </p:sp>
+      <p:sp>
+        <p:nvSpPr>
+          <p:cNvPr id="21" name="Rectangle 20"/>
+          <p:cNvSpPr/>
+          <p:nvPr/>
+        </p:nvSpPr>
+        <p:spPr>
+          <a:xfrm>
+            <a:off x="731520" y="4206240"/>
+            <a:ext cx="82296" cy="1920240"/>
+          </a:xfrm>
+          <a:prstGeom prst="rect">
+            <a:avLst/>
+          </a:prstGeom>
+          <a:solidFill>
+            <a:srgbClr val="F2B418"/>
+          </a:solidFill>
+          <a:ln>
+            <a:noFill/>
+          </a:ln>
+          <a:effectLst/>
+        </p:spPr>
+        <p:style>
+          <a:lnRef idx="1">
+            <a:schemeClr val="accent1"/>
+          </a:lnRef>
+          <a:fillRef idx="3">
+            <a:schemeClr val="accent1"/>
+          </a:fillRef>
+          <a:effectRef idx="2">
+            <a:schemeClr val="accent1"/>
+          </a:effectRef>
+          <a:fontRef idx="minor">
+            <a:schemeClr val="lt1"/>
+          </a:fontRef>
+        </p:style>
+        <p:txBody>
+          <a:bodyPr rtlCol="0" anchor="ctr"/>
+          <a:lstStyle/>
+          <a:p>
+            <a:pPr algn="ctr"/>
+          </a:p>
+        </p:txBody>
+      </p:sp>
+      <p:sp>
+        <p:nvSpPr>
+          <p:cNvPr id="22" name="TextBox 21"/>
+          <p:cNvSpPr txBox="1"/>
+          <p:nvPr/>
+        </p:nvSpPr>
+        <p:spPr>
+          <a:xfrm>
+            <a:off x="1005840" y="4315968"/>
+            <a:ext cx="2834640" cy="411480"/>
+          </a:xfrm>
+          <a:prstGeom prst="rect">
+            <a:avLst/>
+          </a:prstGeom>
+          <a:noFill/>
+        </p:spPr>
+        <p:txBody>
+          <a:bodyPr wrap="square" anchor="ctr" lIns="0" rIns="0" tIns="0" bIns="0">
+            <a:spAutoFit/>
+          </a:bodyPr>
+          <a:lstStyle/>
+          <a:p>
+            <a:pPr algn="l"/>
+            <a:r>
+              <a:rPr sz="1500" b="1">
+                <a:solidFill>
+                  <a:srgbClr val="0F2A4C"/>
+                </a:solidFill>
+                <a:latin typeface="Calibri"/>
+              </a:rPr>
+              <a:t>Active Immediately</a:t>
+            </a:r>
+          </a:p>
+        </p:txBody>
+      </p:sp>
+      <p:sp>
+        <p:nvSpPr>
+          <p:cNvPr id="23" name="TextBox 22"/>
+          <p:cNvSpPr txBox="1"/>
+          <p:nvPr/>
+        </p:nvSpPr>
+        <p:spPr>
+          <a:xfrm>
+            <a:off x="1005840" y="4681728"/>
+            <a:ext cx="2834640" cy="1371600"/>
+          </a:xfrm>
+          <a:prstGeom prst="rect">
+            <a:avLst/>
+          </a:prstGeom>
+          <a:noFill/>
+        </p:spPr>
+        <p:txBody>
+          <a:bodyPr wrap="square" anchor="t" lIns="0" rIns="0" tIns="0" bIns="0">
+            <a:spAutoFit/>
+          </a:bodyPr>
+          <a:lstStyle/>
+          <a:p>
+            <a:pPr algn="l">
+              <a:lnSpc>
+                <a:spcPct val="110000"/>
+              </a:lnSpc>
+            </a:pPr>
+            <a:r>
+              <a:rPr sz="1500" b="0">
+                <a:solidFill>
+                  <a:srgbClr val="243244"/>
+                </a:solidFill>
+                <a:latin typeface="Calibri"/>
+              </a:rPr>
+              <a:t>No verification email, no approval queue - ready at once.</a:t>
+            </a:r>
+          </a:p>
+        </p:txBody>
+      </p:sp>
+      <p:sp>
+        <p:nvSpPr>
+          <p:cNvPr id="24" name="Rounded Rectangle 23"/>
+          <p:cNvSpPr/>
+          <p:nvPr/>
+        </p:nvSpPr>
+        <p:spPr>
+          <a:xfrm>
+            <a:off x="4343400" y="4206240"/>
+            <a:ext cx="3291840" cy="1920240"/>
+          </a:xfrm>
+          <a:prstGeom prst="roundRect">
+            <a:avLst/>
+          </a:prstGeom>
+          <a:solidFill>
+            <a:srgbClr val="FFFFFF"/>
+          </a:solidFill>
+          <a:ln>
+            <a:noFill/>
+          </a:ln>
+          <a:effectLst/>
+        </p:spPr>
+        <p:style>
+          <a:lnRef idx="1">
+            <a:schemeClr val="accent1"/>
+          </a:lnRef>
+          <a:fillRef idx="3">
+            <a:schemeClr val="accent1"/>
+          </a:fillRef>
+          <a:effectRef idx="2">
+            <a:schemeClr val="accent1"/>
+          </a:effectRef>
+          <a:fontRef idx="minor">
+            <a:schemeClr val="lt1"/>
+          </a:fontRef>
+        </p:style>
+        <p:txBody>
+          <a:bodyPr rtlCol="0" anchor="ctr"/>
+          <a:lstStyle/>
+          <a:p>
+            <a:pPr algn="ctr"/>
+          </a:p>
+        </p:txBody>
+      </p:sp>
+      <p:sp>
+        <p:nvSpPr>
+          <p:cNvPr id="25" name="Rectangle 24"/>
+          <p:cNvSpPr/>
+          <p:nvPr/>
+        </p:nvSpPr>
+        <p:spPr>
+          <a:xfrm>
+            <a:off x="4343400" y="4206240"/>
+            <a:ext cx="82296" cy="1920240"/>
+          </a:xfrm>
+          <a:prstGeom prst="rect">
+            <a:avLst/>
+          </a:prstGeom>
+          <a:solidFill>
+            <a:srgbClr val="F2B418"/>
+          </a:solidFill>
+          <a:ln>
+            <a:noFill/>
+          </a:ln>
+          <a:effectLst/>
+        </p:spPr>
+        <p:style>
+          <a:lnRef idx="1">
+            <a:schemeClr val="accent1"/>
+          </a:lnRef>
+          <a:fillRef idx="3">
+            <a:schemeClr val="accent1"/>
+          </a:fillRef>
+          <a:effectRef idx="2">
+            <a:schemeClr val="accent1"/>
+          </a:effectRef>
+          <a:fontRef idx="minor">
+            <a:schemeClr val="lt1"/>
+          </a:fontRef>
+        </p:style>
+        <p:txBody>
+          <a:bodyPr rtlCol="0" anchor="ctr"/>
+          <a:lstStyle/>
+          <a:p>
+            <a:pPr algn="ctr"/>
+          </a:p>
+        </p:txBody>
+      </p:sp>
+      <p:sp>
+        <p:nvSpPr>
+          <p:cNvPr id="26" name="TextBox 25"/>
+          <p:cNvSpPr txBox="1"/>
+          <p:nvPr/>
+        </p:nvSpPr>
+        <p:spPr>
+          <a:xfrm>
+            <a:off x="4617720" y="4315968"/>
+            <a:ext cx="2834640" cy="411480"/>
+          </a:xfrm>
+          <a:prstGeom prst="rect">
+            <a:avLst/>
+          </a:prstGeom>
+          <a:noFill/>
+        </p:spPr>
+        <p:txBody>
+          <a:bodyPr wrap="square" anchor="ctr" lIns="0" rIns="0" tIns="0" bIns="0">
+            <a:spAutoFit/>
+          </a:bodyPr>
+          <a:lstStyle/>
+          <a:p>
+            <a:pPr algn="l"/>
+            <a:r>
+              <a:rPr sz="1500" b="1">
+                <a:solidFill>
+                  <a:srgbClr val="0F2A4C"/>
+                </a:solidFill>
+                <a:latin typeface="Calibri"/>
+              </a:rPr>
+              <a:t>No Public Signup</a:t>
+            </a:r>
+          </a:p>
+        </p:txBody>
+      </p:sp>
+      <p:sp>
+        <p:nvSpPr>
+          <p:cNvPr id="27" name="TextBox 26"/>
+          <p:cNvSpPr txBox="1"/>
+          <p:nvPr/>
+        </p:nvSpPr>
+        <p:spPr>
+          <a:xfrm>
+            <a:off x="4617720" y="4681728"/>
+            <a:ext cx="2834640" cy="1371600"/>
+          </a:xfrm>
+          <a:prstGeom prst="rect">
+            <a:avLst/>
+          </a:prstGeom>
+          <a:noFill/>
+        </p:spPr>
+        <p:txBody>
+          <a:bodyPr wrap="square" anchor="t" lIns="0" rIns="0" tIns="0" bIns="0">
+            <a:spAutoFit/>
+          </a:bodyPr>
+          <a:lstStyle/>
+          <a:p>
+            <a:pPr algn="l">
+              <a:lnSpc>
+                <a:spcPct val="110000"/>
+              </a:lnSpc>
+            </a:pPr>
+            <a:r>
+              <a:rPr sz="1500" b="0">
+                <a:solidFill>
+                  <a:srgbClr val="243244"/>
+                </a:solidFill>
+                <a:latin typeface="Calibri"/>
+              </a:rPr>
+              <a:t>Self-signup and email OTP were removed from the portal.</a:t>
+            </a:r>
+          </a:p>
+        </p:txBody>
+      </p:sp>
+      <p:sp>
+        <p:nvSpPr>
+          <p:cNvPr id="28" name="Rounded Rectangle 27"/>
+          <p:cNvSpPr/>
+          <p:nvPr/>
+        </p:nvSpPr>
+        <p:spPr>
+          <a:xfrm>
+            <a:off x="7955279" y="4206240"/>
+            <a:ext cx="3291840" cy="1920240"/>
+          </a:xfrm>
+          <a:prstGeom prst="roundRect">
+            <a:avLst/>
+          </a:prstGeom>
+          <a:solidFill>
+            <a:srgbClr val="FFFFFF"/>
+          </a:solidFill>
+          <a:ln>
+            <a:noFill/>
+          </a:ln>
+          <a:effectLst/>
+        </p:spPr>
+        <p:style>
+          <a:lnRef idx="1">
+            <a:schemeClr val="accent1"/>
+          </a:lnRef>
+          <a:fillRef idx="3">
+            <a:schemeClr val="accent1"/>
+          </a:fillRef>
+          <a:effectRef idx="2">
+            <a:schemeClr val="accent1"/>
+          </a:effectRef>
+          <a:fontRef idx="minor">
+            <a:schemeClr val="lt1"/>
+          </a:fontRef>
+        </p:style>
+        <p:txBody>
+          <a:bodyPr rtlCol="0" anchor="ctr"/>
+          <a:lstStyle/>
+          <a:p>
+            <a:pPr algn="ctr"/>
+          </a:p>
+        </p:txBody>
+      </p:sp>
+      <p:sp>
+        <p:nvSpPr>
+          <p:cNvPr id="29" name="Rectangle 28"/>
+          <p:cNvSpPr/>
+          <p:nvPr/>
+        </p:nvSpPr>
+        <p:spPr>
+          <a:xfrm>
+            <a:off x="7955279" y="4206240"/>
+            <a:ext cx="82296" cy="1920240"/>
+          </a:xfrm>
+          <a:prstGeom prst="rect">
+            <a:avLst/>
+          </a:prstGeom>
+          <a:solidFill>
+            <a:srgbClr val="F2B418"/>
+          </a:solidFill>
+          <a:ln>
+            <a:noFill/>
+          </a:ln>
+          <a:effectLst/>
+        </p:spPr>
+        <p:style>
+          <a:lnRef idx="1">
+            <a:schemeClr val="accent1"/>
+          </a:lnRef>
+          <a:fillRef idx="3">
+            <a:schemeClr val="accent1"/>
+          </a:fillRef>
+          <a:effectRef idx="2">
+            <a:schemeClr val="accent1"/>
+          </a:effectRef>
+          <a:fontRef idx="minor">
+            <a:schemeClr val="lt1"/>
+          </a:fontRef>
+        </p:style>
+        <p:txBody>
+          <a:bodyPr rtlCol="0" anchor="ctr"/>
+          <a:lstStyle/>
+          <a:p>
+            <a:pPr algn="ctr"/>
+          </a:p>
+        </p:txBody>
+      </p:sp>
+      <p:sp>
+        <p:nvSpPr>
+          <p:cNvPr id="30" name="TextBox 29"/>
+          <p:cNvSpPr txBox="1"/>
+          <p:nvPr/>
+        </p:nvSpPr>
+        <p:spPr>
+          <a:xfrm>
+            <a:off x="8229599" y="4315968"/>
+            <a:ext cx="2834640" cy="411480"/>
+          </a:xfrm>
+          <a:prstGeom prst="rect">
+            <a:avLst/>
+          </a:prstGeom>
+          <a:noFill/>
+        </p:spPr>
+        <p:txBody>
+          <a:bodyPr wrap="square" anchor="ctr" lIns="0" rIns="0" tIns="0" bIns="0">
+            <a:spAutoFit/>
+          </a:bodyPr>
+          <a:lstStyle/>
+          <a:p>
+            <a:pPr algn="l"/>
+            <a:r>
+              <a:rPr sz="1500" b="1">
+                <a:solidFill>
+                  <a:srgbClr val="0F2A4C"/>
+                </a:solidFill>
+                <a:latin typeface="Calibri"/>
+              </a:rPr>
+              <a:t>Secure Defaults</a:t>
+            </a:r>
+          </a:p>
+        </p:txBody>
+      </p:sp>
+      <p:sp>
+        <p:nvSpPr>
+          <p:cNvPr id="31" name="TextBox 30"/>
+          <p:cNvSpPr txBox="1"/>
+          <p:nvPr/>
+        </p:nvSpPr>
+        <p:spPr>
+          <a:xfrm>
+            <a:off x="8229599" y="4681728"/>
+            <a:ext cx="2834640" cy="1371600"/>
+          </a:xfrm>
+          <a:prstGeom prst="rect">
+            <a:avLst/>
+          </a:prstGeom>
+          <a:noFill/>
+        </p:spPr>
+        <p:txBody>
+          <a:bodyPr wrap="square" anchor="t" lIns="0" rIns="0" tIns="0" bIns="0">
+            <a:spAutoFit/>
+          </a:bodyPr>
+          <a:lstStyle/>
+          <a:p>
+            <a:pPr algn="l">
+              <a:lnSpc>
+                <a:spcPct val="110000"/>
+              </a:lnSpc>
+            </a:pPr>
+            <a:r>
+              <a:rPr sz="1500" b="0">
+                <a:solidFill>
+                  <a:srgbClr val="243244"/>
+                </a:solidFill>
+                <a:latin typeface="Calibri"/>
+              </a:rPr>
+              <a:t>Common default passwords are refused and bcrypt-hashed.</a:t>
             </a:r>
           </a:p>
         </p:txBody>

</xml_diff>